<commit_message>
Use only 2021-2026 sources in both reports
- UniGuard: replace pre-2021 references with 2021-2026 papers on
  ransomware entropy detection, backup economics, encrypted
  deduplication, memory-hard KDFs, hash-chain logging, Nigerian
  university cybersecurity readiness and campus power outages; cite
  NIST CSF 2.0, SP 800-61r3, Pfleeger 6th ed. and the 2024 Cybercrimes
  Amendment Act
- AgroPeace: replace ICG, ACLED 2010, Ushahidi 2009 and RFC citations
  with 2021-2026 studies of the Benue conflict, GIS and GPS tracking of
  herds, conflict early warning systems, crowdsourcing credibility and
  misinformation
- Slides and defense sheets updated to the same sources

Co-Authored-By: Claude Opus 5.5 <noreply@anthropic.com>
Claude-Session: https://claude.ai/code/session_01JZqqg7YJpsctVq4ZMmHoXB
</commit_message>
<xml_diff>
--- a/project1-uniguard/docs/UniGuard_Presentation.pptx
+++ b/project1-uniguard/docs/UniGuard_Presentation.pptx
@@ -1496,7 +1496,7 @@
           <a:p>
             <a:r>
               <a:rPr lang="en-US" dirty="0"/>
-              <a:t>Three numbers frame the problem. The grid collapsed twelve times in 2024, so power cuts are routine. The Data Protection Act gives us 72 hours to report a breach, so we must know quickly. And many departments back up to one drive kept next to the server, which ransomware encrypts along with everything else.</a:t>
+              <a:t>Three numbers frame the problem. In a 2026 survey across Nigerian universities, polytechnics and research institutes, 39 percent of respondents faced 4 to 6 hours of power outage every day, so abrupt power cuts are routine. The Data Protection Act gives us 72 hours to report a breach, so we must know quickly. And many departments back up to one drive kept next to the server, which ransomware encrypts along with everything else.</a:t>
             </a:r>
             <a:endParaRPr lang="en-US" dirty="0"/>
           </a:p>
@@ -2024,7 +2024,7 @@
           <a:p>
             <a:r>
               <a:rPr lang="en-US" dirty="0"/>
-              <a:t>The idea comes from research on CryptoDrop by Scaife and others in 2016: ransomware makes files look random, so their Shannon entropy jumps close to 8 bits per byte. I combine four signals. It needs two or more to go critical, which keeps false alarms down. Compressed formats like PDF and DOCX are excluded from the entropy signal.</a:t>
+              <a:t>Recent studies, such as Lee and colleagues in 2023 and Davies and colleagues in 2022, detect ransomware from file entropy: encrypted files look random, so their Shannon entropy jumps close to 8 bits per byte. Bang and colleagues showed in 2024 that attackers can disguise entropy, which is why I never rely on entropy alone. I combine four signals. It needs two or more to go critical, which keeps false alarms down. Compressed formats like PDF and DOCX are excluded from the entropy signal.</a:t>
             </a:r>
             <a:endParaRPr lang="en-US" dirty="0"/>
           </a:p>
@@ -6762,7 +6762,7 @@
                 <a:ea typeface="Cambria" pitchFamily="34" charset="-122"/>
                 <a:cs typeface="Cambria" pitchFamily="34" charset="-120"/>
               </a:rPr>
-              <a:t>12</a:t>
+              <a:t>39%</a:t>
             </a:r>
             <a:endParaRPr lang="en-US" sz="4400" dirty="0"/>
           </a:p>
@@ -6801,7 +6801,7 @@
                 <a:ea typeface="Calibri" pitchFamily="34" charset="-122"/>
                 <a:cs typeface="Calibri" pitchFamily="34" charset="-120"/>
               </a:rPr>
-              <a:t>national grid collapses in 2024 (Guardian Nigeria). Each cut can corrupt a file mid-write.</a:t>
+              <a:t>of surveyed staff at Nigerian tertiary institutions face 4 to 6 hours of power outage daily (Ibrahim et al., 2026)</a:t>
             </a:r>
             <a:endParaRPr lang="en-US" sz="1400" dirty="0"/>
           </a:p>

</xml_diff>

<commit_message>
Point demo runbooks and speaker notes at the one-command launchers
Co-Authored-By: Claude Opus 5.5 <noreply@anthropic.com>
Claude-Session: https://claude.ai/code/session_01JZqqg7YJpsctVq4ZMmHoXB
</commit_message>
<xml_diff>
--- a/project1-uniguard/docs/UniGuard_Presentation.pptx
+++ b/project1-uniguard/docs/UniGuard_Presentation.pptx
@@ -1232,7 +1232,7 @@
           <a:p>
             <a:r>
               <a:rPr lang="en-US" dirty="0"/>
-              <a:t>Switch to the terminal and browser now. Terminal 1 runs the dashboard, terminal 2 the fake portal, terminal 3 the incident simulator. Run: simulate_incident.py power-off, then Ctrl+C the portal, then tamper, then ransomware. If anything fails, run demo/run_demo.py --fast which tells the same story in the terminal.</a:t>
+              <a:t>Switch to the terminal and browser now. Window 1 runs python demo/live.py --fresh, which starts the dashboard and the stand-in portal. Window 2 runs the incident simulator: power-off, power-on, portal-down, portal-up, tamper, then ransomware. If anything fails, run demo/run_demo.py --fast which tells the same story in the terminal.</a:t>
             </a:r>
             <a:endParaRPr lang="en-US" dirty="0"/>
           </a:p>
@@ -5473,7 +5473,7 @@
                 <a:ea typeface="Calibri" pitchFamily="34" charset="-122"/>
                 <a:cs typeface="Calibri" pitchFamily="34" charset="-120"/>
               </a:rPr>
-              <a:t>Student Portal goes down: critical alert within 3 seconds</a:t>
+              <a:t>Student Portal goes down: critical alert within seconds</a:t>
             </a:r>
             <a:endParaRPr lang="en-US" sz="2000" dirty="0"/>
           </a:p>

</xml_diff>